<commit_message>
fix(tastyr-iq): Fix corrupt PDF, pitch deck gaps, and add redesigned outreach deck
- Fix social-chain-strategy.pdf (was 960 bytes/corrupt due to ReportLab
  flowable reuse bug). Now builds independently with dedicated chain
  content: cover, 8 detailed chains with execution steps, timing
  overview, and health monitoring table (11,625 bytes)
- Fix pitch deck slide 4: Populate right-side feature cards (Text 21-28)
  and left-side dish listings (Text 8-20) across all 4 variations
- Fix pitch deck slide 7: Replace competitive table with Tastyr IQ
  competitor data (Yelp, Google Maps, OpenTable)
- Add redesigned outreach deck (21 slides) with investor-grade design:
  white backgrounds, Calibri typography, green/amber accents, metric
  blocks, process flows, chain strategy diagrams, clean tables

Co-Authored-By: Claude Opus 4.6 <noreply@anthropic.com>
</commit_message>
<xml_diff>
--- a/tastyr-iq/strategy/pitch-deck-v1-investor.pptx
+++ b/tastyr-iq/strategy/pitch-deck-v1-investor.pptx
@@ -6896,7 +6896,7 @@
                 <a:ea typeface="Calibri" pitchFamily="34" charset="-122"/>
                 <a:cs typeface="Calibri" pitchFamily="34" charset="-120"/>
               </a:rPr>
-              <a:t>Italian  ★ 4.9</a:t>
+              <a:t>Japanese  ★ 96/100</a:t>
             </a:r>
             <a:endParaRPr lang="en-US" sz="800" dirty="0"/>
           </a:p>
@@ -6955,7 +6955,7 @@
                 <a:ea typeface="Trebuchet MS" pitchFamily="34" charset="-122"/>
                 <a:cs typeface="Trebuchet MS" pitchFamily="34" charset="-120"/>
               </a:rPr>
-              <a:t>4.9</a:t>
+              <a:t>96</a:t>
             </a:r>
             <a:endParaRPr lang="en-US" sz="900" dirty="0"/>
           </a:p>
@@ -7014,7 +7014,7 @@
                 <a:ea typeface="Trebuchet MS" pitchFamily="34" charset="-122"/>
                 <a:cs typeface="Trebuchet MS" pitchFamily="34" charset="-120"/>
               </a:rPr>
-              <a:t>Sakura Garden</a:t>
+              <a:t>Truffle Mushroom Risotto</a:t>
             </a:r>
             <a:endParaRPr lang="en-US" sz="1000" dirty="0"/>
           </a:p>
@@ -7053,7 +7053,7 @@
                 <a:ea typeface="Calibri" pitchFamily="34" charset="-122"/>
                 <a:cs typeface="Calibri" pitchFamily="34" charset="-120"/>
               </a:rPr>
-              <a:t>Japanese  ★ 4.8</a:t>
+              <a:t>Italian  ★ 94/100</a:t>
             </a:r>
             <a:endParaRPr lang="en-US" sz="800" dirty="0"/>
           </a:p>
@@ -7112,7 +7112,7 @@
                 <a:ea typeface="Trebuchet MS" pitchFamily="34" charset="-122"/>
                 <a:cs typeface="Trebuchet MS" pitchFamily="34" charset="-120"/>
               </a:rPr>
-              <a:t>4.8</a:t>
+              <a:t>94</a:t>
             </a:r>
             <a:endParaRPr lang="en-US" sz="900" dirty="0"/>
           </a:p>
@@ -7171,7 +7171,7 @@
                 <a:ea typeface="Trebuchet MS" pitchFamily="34" charset="-122"/>
                 <a:cs typeface="Trebuchet MS" pitchFamily="34" charset="-120"/>
               </a:rPr>
-              <a:t>Blue Agave</a:t>
+              <a:t>Nashville Hot Chicken</a:t>
             </a:r>
             <a:endParaRPr lang="en-US" sz="1000" dirty="0"/>
           </a:p>
@@ -7210,7 +7210,7 @@
                 <a:ea typeface="Calibri" pitchFamily="34" charset="-122"/>
                 <a:cs typeface="Calibri" pitchFamily="34" charset="-120"/>
               </a:rPr>
-              <a:t>Mexican  ★ 4.7</a:t>
+              <a:t>Southern  ★ 91/100</a:t>
             </a:r>
             <a:endParaRPr lang="en-US" sz="800" dirty="0"/>
           </a:p>
@@ -7269,7 +7269,7 @@
                 <a:ea typeface="Trebuchet MS" pitchFamily="34" charset="-122"/>
                 <a:cs typeface="Trebuchet MS" pitchFamily="34" charset="-120"/>
               </a:rPr>
-              <a:t>4.7</a:t>
+              <a:t>91</a:t>
             </a:r>
             <a:endParaRPr lang="en-US" sz="900" dirty="0"/>
           </a:p>
@@ -7332,7 +7332,7 @@
                 <a:ea typeface="Trebuchet MS" pitchFamily="34" charset="-122"/>
                 <a:cs typeface="Trebuchet MS" pitchFamily="34" charset="-120"/>
               </a:rPr>
-              <a:t>AI Trust Score</a:t>
+              <a:t>Patent-Pending Dish Scores</a:t>
             </a:r>
             <a:endParaRPr lang="en-US" sz="1400" dirty="0"/>
           </a:p>
@@ -7371,7 +7371,7 @@
                 <a:ea typeface="Calibri" pitchFamily="34" charset="-122"/>
                 <a:cs typeface="Calibri" pitchFamily="34" charset="-120"/>
               </a:rPr>
-              <a:t>Every review gets an authenticity score powered by our proprietary ML model</a:t>
+              <a:t>Every dish gets a 0-100 TastyrScore using AI that analyzes flavor, presentation, value, and consistency.</a:t>
             </a:r>
             <a:endParaRPr lang="en-US" sz="1100" dirty="0"/>
           </a:p>
@@ -7434,7 +7434,7 @@
                 <a:ea typeface="Trebuchet MS" pitchFamily="34" charset="-122"/>
                 <a:cs typeface="Trebuchet MS" pitchFamily="34" charset="-120"/>
               </a:rPr>
-              <a:t>Taste DNA</a:t>
+              <a:t>9 Cuisine Vertical AI</a:t>
             </a:r>
             <a:endParaRPr lang="en-US" sz="1400" dirty="0"/>
           </a:p>
@@ -7473,7 +7473,7 @@
                 <a:ea typeface="Calibri" pitchFamily="34" charset="-122"/>
                 <a:cs typeface="Calibri" pitchFamily="34" charset="-120"/>
               </a:rPr>
-              <a:t>Build your preference profile — get recommendations that actually match your taste</a:t>
+              <a:t>Specialized models for each food category — sushi, BBQ, vegan, Italian, and more.</a:t>
             </a:r>
             <a:endParaRPr lang="en-US" sz="1100" dirty="0"/>
           </a:p>
@@ -7536,7 +7536,7 @@
                 <a:ea typeface="Trebuchet MS" pitchFamily="34" charset="-122"/>
                 <a:cs typeface="Trebuchet MS" pitchFamily="34" charset="-120"/>
               </a:rPr>
-              <a:t>Local Pulse</a:t>
+              <a:t>Real-Time Dish Rankings</a:t>
             </a:r>
             <a:endParaRPr lang="en-US" sz="1400" dirty="0"/>
           </a:p>
@@ -7575,7 +7575,7 @@
                 <a:ea typeface="Calibri" pitchFamily="34" charset="-122"/>
                 <a:cs typeface="Calibri" pitchFamily="34" charset="-120"/>
               </a:rPr>
-              <a:t>Real-time trending spots, new openings, and neighborhood activity feed</a:t>
+              <a:t>Live trending dishes, new additions, and neighborhood-level intelligence updated continuously.</a:t>
             </a:r>
             <a:endParaRPr lang="en-US" sz="1100" dirty="0"/>
           </a:p>
@@ -7638,7 +7638,7 @@
                 <a:ea typeface="Trebuchet MS" pitchFamily="34" charset="-122"/>
                 <a:cs typeface="Trebuchet MS" pitchFamily="34" charset="-120"/>
               </a:rPr>
-              <a:t>Business Dashboard</a:t>
+              <a:t>Restaurant Dashboard</a:t>
             </a:r>
             <a:endParaRPr lang="en-US" sz="1400" dirty="0"/>
           </a:p>
@@ -7677,7 +7677,7 @@
                 <a:ea typeface="Calibri" pitchFamily="34" charset="-122"/>
                 <a:cs typeface="Calibri" pitchFamily="34" charset="-120"/>
               </a:rPr>
-              <a:t>Free analytics for businesses — foot traffic, sentiment analysis, competitor benchmarks</a:t>
+              <a:t>Free analytics for restaurants — dish performance, competitive benchmarking, menu optimization insights.</a:t>
             </a:r>
             <a:endParaRPr lang="en-US" sz="1100" dirty="0"/>
           </a:p>
@@ -9470,7 +9470,7 @@
                           <a:ea typeface="Trebuchet MS" pitchFamily="34" charset="-122"/>
                           <a:cs typeface="Trebuchet MS" pitchFamily="34" charset="-120"/>
                         </a:rPr>
-                        <a:t>Locale</a:t>
+                        <a:t>Tastyr IQ</a:t>
                       </a:r>
                       <a:endParaRPr lang="en-US" sz="1100" dirty="0">
                         <a:latin typeface="Trebuchet MS" charset="0"/>
@@ -9674,7 +9674,7 @@
                           <a:ea typeface="Trebuchet MS" pitchFamily="34" charset="-122"/>
                           <a:cs typeface="Trebuchet MS" pitchFamily="34" charset="-120"/>
                         </a:rPr>
-                        <a:t>TripAdvisor</a:t>
+                        <a:t>OpenTable</a:t>
                       </a:r>
                       <a:endParaRPr lang="en-US" sz="1100" dirty="0">
                         <a:latin typeface="Trebuchet MS" charset="0"/>
@@ -9744,7 +9744,7 @@
                           <a:ea typeface="Calibri" pitchFamily="34" charset="-122"/>
                           <a:cs typeface="Calibri" pitchFamily="34" charset="-120"/>
                         </a:rPr>
-                        <a:t>AI Review Verification</a:t>
+                        <a:t>Dish-Level Scores</a:t>
                       </a:r>
                       <a:endParaRPr lang="en-US" sz="1000" dirty="0">
                         <a:latin typeface="Calibri" charset="0"/>
@@ -9948,7 +9948,7 @@
                           <a:ea typeface="Calibri" pitchFamily="34" charset="-122"/>
                           <a:cs typeface="Calibri" pitchFamily="34" charset="-120"/>
                         </a:rPr>
-                        <a:t>Partial</a:t>
+                        <a:t>✗</a:t>
                       </a:r>
                       <a:endParaRPr lang="en-US" sz="1000" dirty="0">
                         <a:latin typeface="Calibri" charset="0"/>
@@ -10086,7 +10086,7 @@
                           <a:ea typeface="Calibri" pitchFamily="34" charset="-122"/>
                           <a:cs typeface="Calibri" pitchFamily="34" charset="-120"/>
                         </a:rPr>
-                        <a:t>Personalized Recs</a:t>
+                        <a:t>AI Scoring Algorithm</a:t>
                       </a:r>
                       <a:endParaRPr lang="en-US" sz="1000" dirty="0">
                         <a:latin typeface="Calibri" charset="0"/>
@@ -10222,75 +10222,7 @@
                           <a:ea typeface="Calibri" pitchFamily="34" charset="-122"/>
                           <a:cs typeface="Calibri" pitchFamily="34" charset="-120"/>
                         </a:rPr>
-                        <a:t>Basic</a:t>
-                      </a:r>
-                      <a:endParaRPr lang="en-US" sz="1000" dirty="0">
-                        <a:latin typeface="Calibri" charset="0"/>
-                        <a:ea typeface="Calibri" charset="0"/>
-                        <a:cs typeface="Calibri" charset="0"/>
-                      </a:endParaRPr>
-                    </a:p>
-                  </a:txBody>
-                  <a:tcPr marL="91440" marR="91440" marT="45720" marB="45720">
-                    <a:lnL w="6350" cap="flat" cmpd="sng" algn="ctr">
-                      <a:solidFill>
-                        <a:srgbClr val="E8ECF4"/>
-                      </a:solidFill>
-                      <a:prstDash val="solid"/>
-                      <a:round/>
-                      <a:headEnd type="none" w="med" len="med"/>
-                      <a:tailEnd type="none" w="med" len="med"/>
-                    </a:lnL>
-                    <a:lnR w="6350" cap="flat" cmpd="sng" algn="ctr">
-                      <a:solidFill>
-                        <a:srgbClr val="E8ECF4"/>
-                      </a:solidFill>
-                      <a:prstDash val="solid"/>
-                      <a:round/>
-                      <a:headEnd type="none" w="med" len="med"/>
-                      <a:tailEnd type="none" w="med" len="med"/>
-                    </a:lnR>
-                    <a:lnT w="6350" cap="flat" cmpd="sng" algn="ctr">
-                      <a:solidFill>
-                        <a:srgbClr val="E8ECF4"/>
-                      </a:solidFill>
-                      <a:prstDash val="solid"/>
-                      <a:round/>
-                      <a:headEnd type="none" w="med" len="med"/>
-                      <a:tailEnd type="none" w="med" len="med"/>
-                    </a:lnT>
-                    <a:lnB w="6350" cap="flat" cmpd="sng" algn="ctr">
-                      <a:solidFill>
-                        <a:srgbClr val="E8ECF4"/>
-                      </a:solidFill>
-                      <a:prstDash val="solid"/>
-                      <a:round/>
-                      <a:headEnd type="none" w="med" len="med"/>
-                      <a:tailEnd type="none" w="med" len="med"/>
-                    </a:lnB>
-                    <a:solidFill>
-                      <a:srgbClr val="E8ECF4"/>
-                    </a:solidFill>
-                  </a:tcPr>
-                </a:tc>
-                <a:tc>
-                  <a:txBody>
-                    <a:bodyPr/>
-                    <a:lstStyle/>
-                    <a:p>
-                      <a:pPr algn="ctr" indent="0" marL="0">
-                        <a:buNone/>
-                      </a:pPr>
-                      <a:r>
-                        <a:rPr lang="en-US" sz="1000" dirty="0">
-                          <a:solidFill>
-                            <a:srgbClr val="4A5068"/>
-                          </a:solidFill>
-                          <a:latin typeface="Calibri" pitchFamily="34" charset="0"/>
-                          <a:ea typeface="Calibri" pitchFamily="34" charset="-122"/>
-                          <a:cs typeface="Calibri" pitchFamily="34" charset="-120"/>
-                        </a:rPr>
-                        <a:t>Basic</a:t>
+                        <a:t>✗</a:t>
                       </a:r>
                       <a:endParaRPr lang="en-US" sz="1000" dirty="0">
                         <a:latin typeface="Calibri" charset="0"/>
@@ -10409,6 +10341,74 @@
                     </a:solidFill>
                   </a:tcPr>
                 </a:tc>
+                <a:tc>
+                  <a:txBody>
+                    <a:bodyPr/>
+                    <a:lstStyle/>
+                    <a:p>
+                      <a:pPr algn="ctr" indent="0" marL="0">
+                        <a:buNone/>
+                      </a:pPr>
+                      <a:r>
+                        <a:rPr lang="en-US" sz="1000" dirty="0">
+                          <a:solidFill>
+                            <a:srgbClr val="4A5068"/>
+                          </a:solidFill>
+                          <a:latin typeface="Calibri" pitchFamily="34" charset="0"/>
+                          <a:ea typeface="Calibri" pitchFamily="34" charset="-122"/>
+                          <a:cs typeface="Calibri" pitchFamily="34" charset="-120"/>
+                        </a:rPr>
+                        <a:t>✗</a:t>
+                      </a:r>
+                      <a:endParaRPr lang="en-US" sz="1000" dirty="0">
+                        <a:latin typeface="Calibri" charset="0"/>
+                        <a:ea typeface="Calibri" charset="0"/>
+                        <a:cs typeface="Calibri" charset="0"/>
+                      </a:endParaRPr>
+                    </a:p>
+                  </a:txBody>
+                  <a:tcPr marL="91440" marR="91440" marT="45720" marB="45720">
+                    <a:lnL w="6350" cap="flat" cmpd="sng" algn="ctr">
+                      <a:solidFill>
+                        <a:srgbClr val="E8ECF4"/>
+                      </a:solidFill>
+                      <a:prstDash val="solid"/>
+                      <a:round/>
+                      <a:headEnd type="none" w="med" len="med"/>
+                      <a:tailEnd type="none" w="med" len="med"/>
+                    </a:lnL>
+                    <a:lnR w="6350" cap="flat" cmpd="sng" algn="ctr">
+                      <a:solidFill>
+                        <a:srgbClr val="E8ECF4"/>
+                      </a:solidFill>
+                      <a:prstDash val="solid"/>
+                      <a:round/>
+                      <a:headEnd type="none" w="med" len="med"/>
+                      <a:tailEnd type="none" w="med" len="med"/>
+                    </a:lnR>
+                    <a:lnT w="6350" cap="flat" cmpd="sng" algn="ctr">
+                      <a:solidFill>
+                        <a:srgbClr val="E8ECF4"/>
+                      </a:solidFill>
+                      <a:prstDash val="solid"/>
+                      <a:round/>
+                      <a:headEnd type="none" w="med" len="med"/>
+                      <a:tailEnd type="none" w="med" len="med"/>
+                    </a:lnT>
+                    <a:lnB w="6350" cap="flat" cmpd="sng" algn="ctr">
+                      <a:solidFill>
+                        <a:srgbClr val="E8ECF4"/>
+                      </a:solidFill>
+                      <a:prstDash val="solid"/>
+                      <a:round/>
+                      <a:headEnd type="none" w="med" len="med"/>
+                      <a:tailEnd type="none" w="med" len="med"/>
+                    </a:lnB>
+                    <a:solidFill>
+                      <a:srgbClr val="E8ECF4"/>
+                    </a:solidFill>
+                  </a:tcPr>
+                </a:tc>
               </a:tr>
               <a:tr h="347472">
                 <a:tc>
@@ -10428,7 +10428,7 @@
                           <a:ea typeface="Calibri" pitchFamily="34" charset="-122"/>
                           <a:cs typeface="Calibri" pitchFamily="34" charset="-120"/>
                         </a:rPr>
-                        <a:t>Free Business Analytics</a:t>
+                        <a:t>9 Cuisine Verticals</a:t>
                       </a:r>
                       <a:endParaRPr lang="en-US" sz="1000" dirty="0">
                         <a:latin typeface="Calibri" charset="0"/>
@@ -10632,7 +10632,7 @@
                           <a:ea typeface="Calibri" pitchFamily="34" charset="-122"/>
                           <a:cs typeface="Calibri" pitchFamily="34" charset="-120"/>
                         </a:rPr>
-                        <a:t>Limited</a:t>
+                        <a:t>✗</a:t>
                       </a:r>
                       <a:endParaRPr lang="en-US" sz="1000" dirty="0">
                         <a:latin typeface="Calibri" charset="0"/>
@@ -10770,7 +10770,7 @@
                           <a:ea typeface="Calibri" pitchFamily="34" charset="-122"/>
                           <a:cs typeface="Calibri" pitchFamily="34" charset="-120"/>
                         </a:rPr>
-                        <a:t>No Pay-to-Play</a:t>
+                        <a:t>Restaurant Dashboard</a:t>
                       </a:r>
                       <a:endParaRPr lang="en-US" sz="1000" dirty="0">
                         <a:latin typeface="Calibri" charset="0"/>
@@ -10906,7 +10906,75 @@
                           <a:ea typeface="Calibri" pitchFamily="34" charset="-122"/>
                           <a:cs typeface="Calibri" pitchFamily="34" charset="-120"/>
                         </a:rPr>
-                        <a:t>✗</a:t>
+                        <a:t>Paid Only</a:t>
+                      </a:r>
+                      <a:endParaRPr lang="en-US" sz="1000" dirty="0">
+                        <a:latin typeface="Calibri" charset="0"/>
+                        <a:ea typeface="Calibri" charset="0"/>
+                        <a:cs typeface="Calibri" charset="0"/>
+                      </a:endParaRPr>
+                    </a:p>
+                  </a:txBody>
+                  <a:tcPr marL="91440" marR="91440" marT="45720" marB="45720">
+                    <a:lnL w="6350" cap="flat" cmpd="sng" algn="ctr">
+                      <a:solidFill>
+                        <a:srgbClr val="E8ECF4"/>
+                      </a:solidFill>
+                      <a:prstDash val="solid"/>
+                      <a:round/>
+                      <a:headEnd type="none" w="med" len="med"/>
+                      <a:tailEnd type="none" w="med" len="med"/>
+                    </a:lnL>
+                    <a:lnR w="6350" cap="flat" cmpd="sng" algn="ctr">
+                      <a:solidFill>
+                        <a:srgbClr val="E8ECF4"/>
+                      </a:solidFill>
+                      <a:prstDash val="solid"/>
+                      <a:round/>
+                      <a:headEnd type="none" w="med" len="med"/>
+                      <a:tailEnd type="none" w="med" len="med"/>
+                    </a:lnR>
+                    <a:lnT w="6350" cap="flat" cmpd="sng" algn="ctr">
+                      <a:solidFill>
+                        <a:srgbClr val="E8ECF4"/>
+                      </a:solidFill>
+                      <a:prstDash val="solid"/>
+                      <a:round/>
+                      <a:headEnd type="none" w="med" len="med"/>
+                      <a:tailEnd type="none" w="med" len="med"/>
+                    </a:lnT>
+                    <a:lnB w="6350" cap="flat" cmpd="sng" algn="ctr">
+                      <a:solidFill>
+                        <a:srgbClr val="E8ECF4"/>
+                      </a:solidFill>
+                      <a:prstDash val="solid"/>
+                      <a:round/>
+                      <a:headEnd type="none" w="med" len="med"/>
+                      <a:tailEnd type="none" w="med" len="med"/>
+                    </a:lnB>
+                    <a:solidFill>
+                      <a:srgbClr val="E8ECF4"/>
+                    </a:solidFill>
+                  </a:tcPr>
+                </a:tc>
+                <a:tc>
+                  <a:txBody>
+                    <a:bodyPr/>
+                    <a:lstStyle/>
+                    <a:p>
+                      <a:pPr algn="ctr" indent="0" marL="0">
+                        <a:buNone/>
+                      </a:pPr>
+                      <a:r>
+                        <a:rPr lang="en-US" sz="1000" dirty="0">
+                          <a:solidFill>
+                            <a:srgbClr val="4A5068"/>
+                          </a:solidFill>
+                          <a:latin typeface="Calibri" pitchFamily="34" charset="0"/>
+                          <a:ea typeface="Calibri" pitchFamily="34" charset="-122"/>
+                          <a:cs typeface="Calibri" pitchFamily="34" charset="-120"/>
+                        </a:rPr>
+                        <a:t>Limited</a:t>
                       </a:r>
                       <a:endParaRPr lang="en-US" sz="1000" dirty="0">
                         <a:latin typeface="Calibri" charset="0"/>
@@ -11025,74 +11093,6 @@
                     </a:solidFill>
                   </a:tcPr>
                 </a:tc>
-                <a:tc>
-                  <a:txBody>
-                    <a:bodyPr/>
-                    <a:lstStyle/>
-                    <a:p>
-                      <a:pPr algn="ctr" indent="0" marL="0">
-                        <a:buNone/>
-                      </a:pPr>
-                      <a:r>
-                        <a:rPr lang="en-US" sz="1000" dirty="0">
-                          <a:solidFill>
-                            <a:srgbClr val="4A5068"/>
-                          </a:solidFill>
-                          <a:latin typeface="Calibri" pitchFamily="34" charset="0"/>
-                          <a:ea typeface="Calibri" pitchFamily="34" charset="-122"/>
-                          <a:cs typeface="Calibri" pitchFamily="34" charset="-120"/>
-                        </a:rPr>
-                        <a:t>✗</a:t>
-                      </a:r>
-                      <a:endParaRPr lang="en-US" sz="1000" dirty="0">
-                        <a:latin typeface="Calibri" charset="0"/>
-                        <a:ea typeface="Calibri" charset="0"/>
-                        <a:cs typeface="Calibri" charset="0"/>
-                      </a:endParaRPr>
-                    </a:p>
-                  </a:txBody>
-                  <a:tcPr marL="91440" marR="91440" marT="45720" marB="45720">
-                    <a:lnL w="6350" cap="flat" cmpd="sng" algn="ctr">
-                      <a:solidFill>
-                        <a:srgbClr val="E8ECF4"/>
-                      </a:solidFill>
-                      <a:prstDash val="solid"/>
-                      <a:round/>
-                      <a:headEnd type="none" w="med" len="med"/>
-                      <a:tailEnd type="none" w="med" len="med"/>
-                    </a:lnL>
-                    <a:lnR w="6350" cap="flat" cmpd="sng" algn="ctr">
-                      <a:solidFill>
-                        <a:srgbClr val="E8ECF4"/>
-                      </a:solidFill>
-                      <a:prstDash val="solid"/>
-                      <a:round/>
-                      <a:headEnd type="none" w="med" len="med"/>
-                      <a:tailEnd type="none" w="med" len="med"/>
-                    </a:lnR>
-                    <a:lnT w="6350" cap="flat" cmpd="sng" algn="ctr">
-                      <a:solidFill>
-                        <a:srgbClr val="E8ECF4"/>
-                      </a:solidFill>
-                      <a:prstDash val="solid"/>
-                      <a:round/>
-                      <a:headEnd type="none" w="med" len="med"/>
-                      <a:tailEnd type="none" w="med" len="med"/>
-                    </a:lnT>
-                    <a:lnB w="6350" cap="flat" cmpd="sng" algn="ctr">
-                      <a:solidFill>
-                        <a:srgbClr val="E8ECF4"/>
-                      </a:solidFill>
-                      <a:prstDash val="solid"/>
-                      <a:round/>
-                      <a:headEnd type="none" w="med" len="med"/>
-                      <a:tailEnd type="none" w="med" len="med"/>
-                    </a:lnB>
-                    <a:solidFill>
-                      <a:srgbClr val="E8ECF4"/>
-                    </a:solidFill>
-                  </a:tcPr>
-                </a:tc>
               </a:tr>
               <a:tr h="347472">
                 <a:tc>
@@ -11112,7 +11112,7 @@
                           <a:ea typeface="Calibri" pitchFamily="34" charset="-122"/>
                           <a:cs typeface="Calibri" pitchFamily="34" charset="-120"/>
                         </a:rPr>
-                        <a:t>Real-time Trending</a:t>
+                        <a:t>Consumer Discovery</a:t>
                       </a:r>
                       <a:endParaRPr lang="en-US" sz="1000" dirty="0">
                         <a:latin typeface="Calibri" charset="0"/>
@@ -11248,7 +11248,7 @@
                           <a:ea typeface="Calibri" pitchFamily="34" charset="-122"/>
                           <a:cs typeface="Calibri" pitchFamily="34" charset="-120"/>
                         </a:rPr>
-                        <a:t>✗</a:t>
+                        <a:t>✓</a:t>
                       </a:r>
                       <a:endParaRPr lang="en-US" sz="1000" dirty="0">
                         <a:latin typeface="Calibri" charset="0"/>
@@ -11316,7 +11316,7 @@
                           <a:ea typeface="Calibri" pitchFamily="34" charset="-122"/>
                           <a:cs typeface="Calibri" pitchFamily="34" charset="-120"/>
                         </a:rPr>
-                        <a:t>Limited</a:t>
+                        <a:t>✓</a:t>
                       </a:r>
                       <a:endParaRPr lang="en-US" sz="1000" dirty="0">
                         <a:latin typeface="Calibri" charset="0"/>
@@ -11384,7 +11384,7 @@
                           <a:ea typeface="Calibri" pitchFamily="34" charset="-122"/>
                           <a:cs typeface="Calibri" pitchFamily="34" charset="-120"/>
                         </a:rPr>
-                        <a:t>✗</a:t>
+                        <a:t>Partial</a:t>
                       </a:r>
                       <a:endParaRPr lang="en-US" sz="1000" dirty="0">
                         <a:latin typeface="Calibri" charset="0"/>
@@ -11454,7 +11454,7 @@
                           <a:ea typeface="Calibri" pitchFamily="34" charset="-122"/>
                           <a:cs typeface="Calibri" pitchFamily="34" charset="-120"/>
                         </a:rPr>
-                        <a:t>Booking Integration</a:t>
+                        <a:t>Menu Optimization</a:t>
                       </a:r>
                       <a:endParaRPr lang="en-US" sz="1000" dirty="0">
                         <a:latin typeface="Calibri" charset="0"/>
@@ -11590,7 +11590,7 @@
                           <a:ea typeface="Calibri" pitchFamily="34" charset="-122"/>
                           <a:cs typeface="Calibri" pitchFamily="34" charset="-120"/>
                         </a:rPr>
-                        <a:t>Partial</a:t>
+                        <a:t>✗</a:t>
                       </a:r>
                       <a:endParaRPr lang="en-US" sz="1000" dirty="0">
                         <a:latin typeface="Calibri" charset="0"/>
@@ -11658,7 +11658,7 @@
                           <a:ea typeface="Calibri" pitchFamily="34" charset="-122"/>
                           <a:cs typeface="Calibri" pitchFamily="34" charset="-120"/>
                         </a:rPr>
-                        <a:t>✓</a:t>
+                        <a:t>✗</a:t>
                       </a:r>
                       <a:endParaRPr lang="en-US" sz="1000" dirty="0">
                         <a:latin typeface="Calibri" charset="0"/>
@@ -11726,7 +11726,7 @@
                           <a:ea typeface="Calibri" pitchFamily="34" charset="-122"/>
                           <a:cs typeface="Calibri" pitchFamily="34" charset="-120"/>
                         </a:rPr>
-                        <a:t>✓</a:t>
+                        <a:t>✗</a:t>
                       </a:r>
                       <a:endParaRPr lang="en-US" sz="1000" dirty="0">
                         <a:latin typeface="Calibri" charset="0"/>
@@ -11796,7 +11796,7 @@
                           <a:ea typeface="Calibri" pitchFamily="34" charset="-122"/>
                           <a:cs typeface="Calibri" pitchFamily="34" charset="-120"/>
                         </a:rPr>
-                        <a:t>Community Trust Score</a:t>
+                        <a:t>Data Licensing</a:t>
                       </a:r>
                       <a:endParaRPr lang="en-US" sz="1000" dirty="0">
                         <a:latin typeface="Calibri" charset="0"/>

</xml_diff>